<commit_message>
Skywise AI FDE: add cost monitoring with Resource Management
New slide 11 and guide section 7: AIP usage & limits, Analysis (All LLMs),
Budgets, and the over-threshold escalation to the solution architect.
Checklist and takeaways updated.

Co-Authored-By: Claude Opus 5.5 <noreply@anthropic.com>
Claude-Session: https://claude.ai/code/session_01HdxEbeqqWM97gKbcNqpjAq
</commit_message>
<xml_diff>
--- a/erm-migration/skywise-ai-fde/Skywise-AI-FDE-Best-Practices.pptx
+++ b/erm-migration/skywise-ai-fde/Skywise-AI-FDE-Best-Practices.pptx
@@ -17,9 +17,10 @@
     <p:sldId id="265" r:id="rId11"/>
     <p:sldId id="266" r:id="rId12"/>
     <p:sldId id="267" r:id="rId13"/>
+    <p:sldId id="268" r:id="rId14"/>
   </p:sldIdLst>
   <p:notesMasterIdLst>
-    <p:notesMasterId r:id="rId14"/>
+    <p:notesMasterId r:id="rId15"/>
   </p:notesMasterIdLst>
   <p:sldSz cx="12192000" cy="6858000"/>
   <p:notesSz cx="6858000" cy="12192000"/>
@@ -118,40 +119,41 @@
   <p:extLst>
     <p:ext uri="{521415D9-36F7-43E2-AB2F-B90AF26B5E84}">
       <p14:sectionLst xmlns:p14="http://schemas.microsoft.com/office/powerpoint/2010/main">
-        <p14:section name="Context" id="{297a381a-4048-3bfb-d801-650fbd2c7419}">
+        <p14:section name="Context" id="{14467d40-8d11-4280-f53d-64b3547c9d7a}">
           <p14:sldIdLst>
             <p14:sldId id="256"/>
             <p14:sldId id="257"/>
             <p14:sldId id="258"/>
           </p14:sldIdLst>
         </p14:section>
-        <p14:section name="Features" id="{193b157b-2497-8476-9fd6-06c77c743d3a}">
+        <p14:section name="Features" id="{0848121c-eb14-42b5-b248-272f0827cfe5}">
           <p14:sldIdLst>
             <p14:sldId id="259"/>
             <p14:sldId id="260"/>
           </p14:sldIdLst>
         </p14:section>
-        <p14:section name="Value" id="{0d1af17a-6b2d-0f9b-1137-7e3f5fb2ff88}">
+        <p14:section name="Value" id="{fdc4444d-beeb-2cfc-d37f-0628dab51270}">
           <p14:sldIdLst>
             <p14:sldId id="261"/>
             <p14:sldId id="262"/>
           </p14:sldIdLst>
         </p14:section>
-        <p14:section name="Limits" id="{53ecbf1d-a12c-75b2-6073-267f85870387}">
+        <p14:section name="Limits" id="{bdd99e5a-c8f7-13fe-6fd6-b3205cf504cb}">
           <p14:sldIdLst>
             <p14:sldId id="263"/>
           </p14:sldIdLst>
         </p14:section>
-        <p14:section name="Tokens" id="{1eedd59e-accf-ab28-7a04-983e33bdb8ea}">
+        <p14:section name="Tokens" id="{3b781319-7c40-50dc-125c-40a7ff23d7da}">
           <p14:sldIdLst>
             <p14:sldId id="264"/>
             <p14:sldId id="265"/>
+            <p14:sldId id="266"/>
           </p14:sldIdLst>
         </p14:section>
-        <p14:section name="Wrap-up" id="{9ff662c5-3745-e8ff-2ce5-4f3abc9371eb}">
+        <p14:section name="Wrap-up" id="{4ffbaae9-a3ee-0222-0315-c02661861a18}">
           <p14:sldIdLst>
-            <p14:sldId id="266"/>
             <p14:sldId id="267"/>
+            <p14:sldId id="268"/>
           </p14:sldIdLst>
         </p14:section>
       </p14:sectionLst>
@@ -736,8 +738,11 @@
           <a:p>
             <a:r>
               <a:rPr lang="en-US" dirty="0"/>
-              <a:t>Here's the whole thing as a checklist: before, during and after every session. It's also on the last page of the document I'm sharing.
-Before: new session, right mode, only the resources needed, unused tools off, the right Gemini model, and a clear goal. During: plan first, read every approval, small steps, watch the tokens, and stop it if it goes in circles. After: review, test on real data, use AIP Evals for functions, merge only what you understand, and save good prompts as skills.</a:t>
+              <a:t>How do we keep an eye on cost? With the Resource Management application.
+One: AIP usage and limits, View usage tab. It shows tokens and requests per minute, per Gemini model and per project, for up to two weeks. Filter to your project and open it to see which resources used the most. This view is about volume and rate limits, not money.
+Two: the Analysis tab is the cost view. Filter by source to All LLMs and group by source, and you get a daily LLM cost chart split by model. Narrow it to your project or usage account.
+Three: Budgets. Our platform admins set a budget on our usage account with notification thresholds.
+And this is the important part, on the right: if the cost goes beyond the threshold, the solution architect is notified, along with the individuals behind the usage, and we review together what drove it and how to fix it. So please check your project's cost once a week; if you see a spike, the token counts in the chat outline will show you which session caused it.</a:t>
             </a:r>
             <a:endParaRPr lang="en-US" dirty="0"/>
           </a:p>
@@ -825,8 +830,8 @@
           <a:p>
             <a:r>
               <a:rPr lang="en-US" dirty="0"/>
-              <a:t>To sum up: treat AI FDE as an engineer you direct, not an autopilot. Keep tasks small and specific. Plan, then act. Verify before you merge. And mind the tokens.
-The full guide is in the document I'm sharing with this deck, including prompt templates and the checklist. Questions?</a:t>
+              <a:t>Here's the whole thing as a checklist: before, during and after every session. It's also on the last page of the document I'm sharing.
+Before: new session, right mode, only the resources needed, unused tools off, the right Gemini model, and a clear goal. During: plan first, read every approval, small steps, watch the tokens, and stop it if it goes in circles. After: review, test on real data, use AIP Evals for functions, merge only what you understand, save good prompts as skills, and check your cost in Resource Management.</a:t>
             </a:r>
             <a:endParaRPr lang="en-US" dirty="0"/>
           </a:p>
@@ -850,6 +855,95 @@
             <a:fld id="{F7021451-1387-4CA6-816F-3879F97B5CBC}" type="slidenum">
               <a:rPr lang="en-US"/>
               <a:t>12</a:t>
+            </a:fld>
+            <a:endParaRPr lang="en-US"/>
+          </a:p>
+        </p:txBody>
+      </p:sp>
+    </p:spTree>
+    <p:extLst>
+      <p:ext uri="{BB962C8B-B14F-4D97-AF65-F5344CB8AC3E}">
+        <p14:creationId xmlns:p14="http://schemas.microsoft.com/office/powerpoint/2010/main" val="1024086991"/>
+      </p:ext>
+    </p:extLst>
+  </p:cSld>
+  <p:clrMapOvr>
+    <a:masterClrMapping/>
+  </p:clrMapOvr>
+</p:notes>
+</file>
+
+<file path=ppt/notesSlides/notesSlide13.xml><?xml version="1.0" encoding="utf-8"?>
+<p:notes xmlns:a="http://schemas.openxmlformats.org/drawingml/2006/main" xmlns:r="http://schemas.openxmlformats.org/officeDocument/2006/relationships" xmlns:p="http://schemas.openxmlformats.org/presentationml/2006/main">
+  <p:cSld>
+    <p:spTree>
+      <p:nvGrpSpPr>
+        <p:cNvPr id="1" name=""/>
+        <p:cNvGrpSpPr/>
+        <p:nvPr/>
+      </p:nvGrpSpPr>
+      <p:grpSpPr>
+        <a:xfrm>
+          <a:off x="0" y="0"/>
+          <a:ext cx="0" cy="0"/>
+          <a:chOff x="0" y="0"/>
+          <a:chExt cx="0" cy="0"/>
+        </a:xfrm>
+      </p:grpSpPr>
+      <p:sp>
+        <p:nvSpPr>
+          <p:cNvPr id="2" name="Slide Image Placeholder 1"/>
+          <p:cNvSpPr>
+            <a:spLocks noGrp="1" noRot="1" noChangeAspect="1"/>
+          </p:cNvSpPr>
+          <p:nvPr>
+            <p:ph type="sldImg"/>
+          </p:nvPr>
+        </p:nvSpPr>
+        <p:spPr/>
+      </p:sp>
+      <p:sp>
+        <p:nvSpPr>
+          <p:cNvPr id="3" name="Notes Placeholder 2"/>
+          <p:cNvSpPr>
+            <a:spLocks noGrp="1"/>
+          </p:cNvSpPr>
+          <p:nvPr>
+            <p:ph type="body" idx="1"/>
+          </p:nvPr>
+        </p:nvSpPr>
+        <p:spPr/>
+        <p:txBody>
+          <a:bodyPr/>
+          <a:lstStyle/>
+          <a:p>
+            <a:r>
+              <a:rPr lang="en-US" dirty="0"/>
+              <a:t>To sum up: treat AI FDE as an engineer you direct, not an autopilot. Keep tasks small and specific. Plan, then act. Verify before you merge. And mind the cost: watch it in Resource Management, because over the threshold the solution architect is notified.
+The full guide is in the document I'm sharing with this deck, including prompt templates and the checklist. Questions?</a:t>
+            </a:r>
+            <a:endParaRPr lang="en-US" dirty="0"/>
+          </a:p>
+        </p:txBody>
+      </p:sp>
+      <p:sp>
+        <p:nvSpPr>
+          <p:cNvPr id="4" name="Slide Number Placeholder 3"/>
+          <p:cNvSpPr>
+            <a:spLocks noGrp="1"/>
+          </p:cNvSpPr>
+          <p:nvPr>
+            <p:ph type="sldNum" sz="quarter" idx="10"/>
+          </p:nvPr>
+        </p:nvSpPr>
+        <p:spPr/>
+        <p:txBody>
+          <a:bodyPr/>
+          <a:lstStyle/>
+          <a:p>
+            <a:fld id="{F7021451-1387-4CA6-816F-3879F97B5CBC}" type="slidenum">
+              <a:rPr lang="en-US"/>
+              <a:t>13</a:t>
             </a:fld>
             <a:endParaRPr lang="en-US"/>
           </a:p>
@@ -2993,7 +3087,7 @@
                   <a:schemeClr val="accent3"/>
                 </a:solidFill>
               </a:rPr>
-              <a:t>CHECKLIST</a:t>
+              <a:t>MONITORING COST</a:t>
             </a:r>
             <a:endParaRPr lang="en-US" sz="1100" dirty="0"/>
           </a:p>
@@ -3031,7 +3125,7 @@
                   <a:schemeClr val="tx1"/>
                 </a:solidFill>
               </a:rPr>
-              <a:t>Before, during and after every session</a:t>
+              <a:t>Track your AI FDE cost in Resource Management</a:t>
             </a:r>
             <a:endParaRPr lang="en-US" sz="3600" dirty="0"/>
           </a:p>
@@ -3039,18 +3133,54 @@
       </p:sp>
       <p:sp>
         <p:nvSpPr>
-          <p:cNvPr id="4" name="ck-0"/>
-          <p:cNvSpPr/>
-          <p:nvPr/>
-        </p:nvSpPr>
-        <p:spPr>
-          <a:xfrm>
-            <a:off x="548640" y="1417320"/>
-            <a:ext cx="3515258" cy="4937760"/>
+          <p:cNvPr id="4" name="rm-sub"/>
+          <p:cNvSpPr txBox="1"/>
+          <p:nvPr/>
+        </p:nvSpPr>
+        <p:spPr>
+          <a:xfrm>
+            <a:off x="548640" y="1143000"/>
+            <a:ext cx="11094415" cy="320040"/>
+          </a:xfrm>
+          <a:prstGeom prst="rect">
+            <a:avLst/>
+          </a:prstGeom>
+          <a:noFill/>
+          <a:ln/>
+        </p:spPr>
+        <p:txBody>
+          <a:bodyPr wrap="square" lIns="0" tIns="0" rIns="0" bIns="0" rtlCol="0" anchor="t"/>
+          <a:lstStyle/>
+          <a:p>
+            <a:pPr indent="0" marL="0">
+              <a:buNone/>
+            </a:pPr>
+            <a:r>
+              <a:rPr lang="en-US" sz="1400" dirty="0">
+                <a:solidFill>
+                  <a:schemeClr val="tx2"/>
+                </a:solidFill>
+              </a:rPr>
+              <a:t>Every message spends Gemini tokens, and tokens are cost. Resource Management shows what you spend, by project and by model.</a:t>
+            </a:r>
+            <a:endParaRPr lang="en-US" sz="1400" dirty="0"/>
+          </a:p>
+        </p:txBody>
+      </p:sp>
+      <p:sp>
+        <p:nvSpPr>
+          <p:cNvPr id="5" name="rm-0"/>
+          <p:cNvSpPr/>
+          <p:nvPr/>
+        </p:nvSpPr>
+        <p:spPr>
+          <a:xfrm>
+            <a:off x="548640" y="1645920"/>
+            <a:ext cx="6675120" cy="1097280"/>
           </a:xfrm>
           <a:prstGeom prst="roundRect">
             <a:avLst>
-              <a:gd name="adj" fmla="val 3121"/>
+              <a:gd name="adj" fmla="val 10000"/>
             </a:avLst>
           </a:prstGeom>
           <a:solidFill>
@@ -3061,16 +3191,16 @@
       </p:sp>
       <p:sp>
         <p:nvSpPr>
-          <p:cNvPr id="5" name="ck-0-bar"/>
-          <p:cNvSpPr/>
-          <p:nvPr/>
-        </p:nvSpPr>
-        <p:spPr>
-          <a:xfrm>
-            <a:off x="548640" y="1417320"/>
-            <a:ext cx="3515258" cy="109728"/>
-          </a:xfrm>
-          <a:prstGeom prst="rect">
+          <p:cNvPr id="6" name="rm-0-n"/>
+          <p:cNvSpPr/>
+          <p:nvPr/>
+        </p:nvSpPr>
+        <p:spPr>
+          <a:xfrm>
+            <a:off x="777240" y="1938528"/>
+            <a:ext cx="512064" cy="512064"/>
+          </a:xfrm>
+          <a:prstGeom prst="ellipse">
             <a:avLst/>
           </a:prstGeom>
           <a:solidFill>
@@ -3081,35 +3211,35 @@
       </p:sp>
       <p:sp>
         <p:nvSpPr>
-          <p:cNvPr id="6" name="ck-0-h"/>
+          <p:cNvPr id="7" name="rm-0-nt"/>
           <p:cNvSpPr txBox="1"/>
           <p:nvPr/>
         </p:nvSpPr>
         <p:spPr>
           <a:xfrm>
-            <a:off x="822960" y="1691640"/>
-            <a:ext cx="2966618" cy="365760"/>
-          </a:xfrm>
-          <a:prstGeom prst="rect">
-            <a:avLst/>
-          </a:prstGeom>
-          <a:noFill/>
-          <a:ln/>
-        </p:spPr>
-        <p:txBody>
-          <a:bodyPr wrap="square" lIns="0" tIns="0" rIns="0" bIns="0" rtlCol="0" anchor="t"/>
-          <a:lstStyle/>
-          <a:p>
-            <a:pPr indent="0" marL="0">
-              <a:buNone/>
-            </a:pPr>
-            <a:r>
-              <a:rPr lang="en-US" sz="1800" b="1" spc="200" kern="0" dirty="0">
-                <a:solidFill>
-                  <a:schemeClr val="accent1"/>
-                </a:solidFill>
-              </a:rPr>
-              <a:t>BEFORE</a:t>
+            <a:off x="777240" y="1938528"/>
+            <a:ext cx="512064" cy="512064"/>
+          </a:xfrm>
+          <a:prstGeom prst="rect">
+            <a:avLst/>
+          </a:prstGeom>
+          <a:noFill/>
+          <a:ln/>
+        </p:spPr>
+        <p:txBody>
+          <a:bodyPr wrap="square" lIns="0" tIns="0" rIns="0" bIns="0" rtlCol="0" anchor="ctr"/>
+          <a:lstStyle/>
+          <a:p>
+            <a:pPr algn="ctr" indent="0" marL="0">
+              <a:buNone/>
+            </a:pPr>
+            <a:r>
+              <a:rPr lang="en-US" sz="1800" b="1" dirty="0">
+                <a:solidFill>
+                  <a:schemeClr val="bg1"/>
+                </a:solidFill>
+              </a:rPr>
+              <a:t>1</a:t>
             </a:r>
             <a:endParaRPr lang="en-US" sz="1800" dirty="0"/>
           </a:p>
@@ -3117,125 +3247,68 @@
       </p:sp>
       <p:sp>
         <p:nvSpPr>
-          <p:cNvPr id="7" name="ck-0-l"/>
+          <p:cNvPr id="8" name="rm-0-t"/>
           <p:cNvSpPr txBox="1"/>
           <p:nvPr/>
         </p:nvSpPr>
         <p:spPr>
           <a:xfrm>
-            <a:off x="822960" y="2194560"/>
-            <a:ext cx="2966618" cy="4023360"/>
-          </a:xfrm>
-          <a:prstGeom prst="rect">
-            <a:avLst/>
-          </a:prstGeom>
-          <a:noFill/>
-          <a:ln/>
-        </p:spPr>
-        <p:txBody>
-          <a:bodyPr wrap="square" lIns="0" tIns="0" rIns="0" bIns="0" rtlCol="0" anchor="t"/>
-          <a:lstStyle/>
-          <a:p>
-            <a:pPr indent="0" marL="0">
-              <a:spcAft>
-                <a:spcPts val="1400"/>
-              </a:spcAft>
-              <a:buNone/>
-            </a:pPr>
-            <a:r>
-              <a:rPr lang="en-US" sz="1500" dirty="0">
+            <a:off x="1508760" y="1645920"/>
+            <a:ext cx="5486400" cy="1097280"/>
+          </a:xfrm>
+          <a:prstGeom prst="rect">
+            <a:avLst/>
+          </a:prstGeom>
+          <a:noFill/>
+          <a:ln/>
+        </p:spPr>
+        <p:txBody>
+          <a:bodyPr wrap="square" lIns="0" tIns="0" rIns="0" bIns="0" rtlCol="0" anchor="ctr"/>
+          <a:lstStyle/>
+          <a:p>
+            <a:pPr indent="0" marL="0">
+              <a:buNone/>
+            </a:pPr>
+            <a:r>
+              <a:rPr lang="en-US" sz="1500" b="1" dirty="0">
                 <a:solidFill>
                   <a:schemeClr val="tx1"/>
                 </a:solidFill>
               </a:rPr>
-              <a:t>☐  New session, right mode</a:t>
+              <a:t>AIP usage &amp; limits › View usage</a:t>
             </a:r>
             <a:endParaRPr lang="en-US" sz="1500" dirty="0"/>
           </a:p>
           <a:p>
             <a:pPr indent="0" marL="0">
-              <a:spcAft>
-                <a:spcPts val="1400"/>
-              </a:spcAft>
-              <a:buNone/>
-            </a:pPr>
-            <a:r>
-              <a:rPr lang="en-US" sz="1500" dirty="0">
-                <a:solidFill>
-                  <a:schemeClr val="tx1"/>
-                </a:solidFill>
-              </a:rPr>
-              <a:t>☐  Attach only the resources needed</a:t>
+              <a:buNone/>
+            </a:pPr>
+            <a:r>
+              <a:rPr lang="en-US" sz="1200" dirty="0">
+                <a:solidFill>
+                  <a:schemeClr val="tx2"/>
+                </a:solidFill>
+              </a:rPr>
+              <a:t>Tokens and requests per minute, by model and by project, for up to two weeks. Filter to your project; open it to see usage per resource.</a:t>
             </a:r>
             <a:endParaRPr lang="en-US" sz="1500" dirty="0"/>
           </a:p>
-          <a:p>
-            <a:pPr indent="0" marL="0">
-              <a:spcAft>
-                <a:spcPts val="1400"/>
-              </a:spcAft>
-              <a:buNone/>
-            </a:pPr>
-            <a:r>
-              <a:rPr lang="en-US" sz="1500" dirty="0">
-                <a:solidFill>
-                  <a:schemeClr val="tx1"/>
-                </a:solidFill>
-              </a:rPr>
-              <a:t>☐  Switch off unused tools</a:t>
-            </a:r>
-            <a:endParaRPr lang="en-US" sz="1500" dirty="0"/>
-          </a:p>
-          <a:p>
-            <a:pPr indent="0" marL="0">
-              <a:spcAft>
-                <a:spcPts val="1400"/>
-              </a:spcAft>
-              <a:buNone/>
-            </a:pPr>
-            <a:r>
-              <a:rPr lang="en-US" sz="1500" dirty="0">
-                <a:solidFill>
-                  <a:schemeClr val="tx1"/>
-                </a:solidFill>
-              </a:rPr>
-              <a:t>☐  Gemini model to match the task</a:t>
-            </a:r>
-            <a:endParaRPr lang="en-US" sz="1500" dirty="0"/>
-          </a:p>
-          <a:p>
-            <a:pPr indent="0" marL="0">
-              <a:spcAft>
-                <a:spcPts val="1400"/>
-              </a:spcAft>
-              <a:buNone/>
-            </a:pPr>
-            <a:r>
-              <a:rPr lang="en-US" sz="1500" dirty="0">
-                <a:solidFill>
-                  <a:schemeClr val="tx1"/>
-                </a:solidFill>
-              </a:rPr>
-              <a:t>☐  Write the goal, rules and checks</a:t>
-            </a:r>
-            <a:endParaRPr lang="en-US" sz="1500" dirty="0"/>
-          </a:p>
-        </p:txBody>
-      </p:sp>
-      <p:sp>
-        <p:nvSpPr>
-          <p:cNvPr id="8" name="ck-1"/>
-          <p:cNvSpPr/>
-          <p:nvPr/>
-        </p:nvSpPr>
-        <p:spPr>
-          <a:xfrm>
-            <a:off x="4338218" y="1417320"/>
-            <a:ext cx="3515258" cy="4937760"/>
+        </p:txBody>
+      </p:sp>
+      <p:sp>
+        <p:nvSpPr>
+          <p:cNvPr id="9" name="rm-1"/>
+          <p:cNvSpPr/>
+          <p:nvPr/>
+        </p:nvSpPr>
+        <p:spPr>
+          <a:xfrm>
+            <a:off x="548640" y="2852928"/>
+            <a:ext cx="6675120" cy="1097280"/>
           </a:xfrm>
           <a:prstGeom prst="roundRect">
             <a:avLst>
-              <a:gd name="adj" fmla="val 3121"/>
+              <a:gd name="adj" fmla="val 10000"/>
             </a:avLst>
           </a:prstGeom>
           <a:solidFill>
@@ -3246,16 +3319,16 @@
       </p:sp>
       <p:sp>
         <p:nvSpPr>
-          <p:cNvPr id="9" name="ck-1-bar"/>
-          <p:cNvSpPr/>
-          <p:nvPr/>
-        </p:nvSpPr>
-        <p:spPr>
-          <a:xfrm>
-            <a:off x="4338218" y="1417320"/>
-            <a:ext cx="3515258" cy="109728"/>
-          </a:xfrm>
-          <a:prstGeom prst="rect">
+          <p:cNvPr id="10" name="rm-1-n"/>
+          <p:cNvSpPr/>
+          <p:nvPr/>
+        </p:nvSpPr>
+        <p:spPr>
+          <a:xfrm>
+            <a:off x="777240" y="3145536"/>
+            <a:ext cx="512064" cy="512064"/>
+          </a:xfrm>
+          <a:prstGeom prst="ellipse">
             <a:avLst/>
           </a:prstGeom>
           <a:solidFill>
@@ -3266,35 +3339,35 @@
       </p:sp>
       <p:sp>
         <p:nvSpPr>
-          <p:cNvPr id="10" name="ck-1-h"/>
+          <p:cNvPr id="11" name="rm-1-nt"/>
           <p:cNvSpPr txBox="1"/>
           <p:nvPr/>
         </p:nvSpPr>
         <p:spPr>
           <a:xfrm>
-            <a:off x="4612538" y="1691640"/>
-            <a:ext cx="2966618" cy="365760"/>
-          </a:xfrm>
-          <a:prstGeom prst="rect">
-            <a:avLst/>
-          </a:prstGeom>
-          <a:noFill/>
-          <a:ln/>
-        </p:spPr>
-        <p:txBody>
-          <a:bodyPr wrap="square" lIns="0" tIns="0" rIns="0" bIns="0" rtlCol="0" anchor="t"/>
-          <a:lstStyle/>
-          <a:p>
-            <a:pPr indent="0" marL="0">
-              <a:buNone/>
-            </a:pPr>
-            <a:r>
-              <a:rPr lang="en-US" sz="1800" b="1" spc="200" kern="0" dirty="0">
-                <a:solidFill>
-                  <a:schemeClr val="accent2"/>
-                </a:solidFill>
-              </a:rPr>
-              <a:t>DURING</a:t>
+            <a:off x="777240" y="3145536"/>
+            <a:ext cx="512064" cy="512064"/>
+          </a:xfrm>
+          <a:prstGeom prst="rect">
+            <a:avLst/>
+          </a:prstGeom>
+          <a:noFill/>
+          <a:ln/>
+        </p:spPr>
+        <p:txBody>
+          <a:bodyPr wrap="square" lIns="0" tIns="0" rIns="0" bIns="0" rtlCol="0" anchor="ctr"/>
+          <a:lstStyle/>
+          <a:p>
+            <a:pPr algn="ctr" indent="0" marL="0">
+              <a:buNone/>
+            </a:pPr>
+            <a:r>
+              <a:rPr lang="en-US" sz="1800" b="1" dirty="0">
+                <a:solidFill>
+                  <a:schemeClr val="bg1"/>
+                </a:solidFill>
+              </a:rPr>
+              <a:t>2</a:t>
             </a:r>
             <a:endParaRPr lang="en-US" sz="1800" dirty="0"/>
           </a:p>
@@ -3302,125 +3375,68 @@
       </p:sp>
       <p:sp>
         <p:nvSpPr>
-          <p:cNvPr id="11" name="ck-1-l"/>
+          <p:cNvPr id="12" name="rm-1-t"/>
           <p:cNvSpPr txBox="1"/>
           <p:nvPr/>
         </p:nvSpPr>
         <p:spPr>
           <a:xfrm>
-            <a:off x="4612538" y="2194560"/>
-            <a:ext cx="2966618" cy="4023360"/>
-          </a:xfrm>
-          <a:prstGeom prst="rect">
-            <a:avLst/>
-          </a:prstGeom>
-          <a:noFill/>
-          <a:ln/>
-        </p:spPr>
-        <p:txBody>
-          <a:bodyPr wrap="square" lIns="0" tIns="0" rIns="0" bIns="0" rtlCol="0" anchor="t"/>
-          <a:lstStyle/>
-          <a:p>
-            <a:pPr indent="0" marL="0">
-              <a:spcAft>
-                <a:spcPts val="1400"/>
-              </a:spcAft>
-              <a:buNone/>
-            </a:pPr>
-            <a:r>
-              <a:rPr lang="en-US" sz="1500" dirty="0">
+            <a:off x="1508760" y="2852928"/>
+            <a:ext cx="5486400" cy="1097280"/>
+          </a:xfrm>
+          <a:prstGeom prst="rect">
+            <a:avLst/>
+          </a:prstGeom>
+          <a:noFill/>
+          <a:ln/>
+        </p:spPr>
+        <p:txBody>
+          <a:bodyPr wrap="square" lIns="0" tIns="0" rIns="0" bIns="0" rtlCol="0" anchor="ctr"/>
+          <a:lstStyle/>
+          <a:p>
+            <a:pPr indent="0" marL="0">
+              <a:buNone/>
+            </a:pPr>
+            <a:r>
+              <a:rPr lang="en-US" sz="1500" b="1" dirty="0">
                 <a:solidFill>
                   <a:schemeClr val="tx1"/>
                 </a:solidFill>
               </a:rPr>
-              <a:t>☐  Ask for a plan; review it</a:t>
+              <a:t>Analysis</a:t>
             </a:r>
             <a:endParaRPr lang="en-US" sz="1500" dirty="0"/>
           </a:p>
           <a:p>
             <a:pPr indent="0" marL="0">
-              <a:spcAft>
-                <a:spcPts val="1400"/>
-              </a:spcAft>
-              <a:buNone/>
-            </a:pPr>
-            <a:r>
-              <a:rPr lang="en-US" sz="1500" dirty="0">
-                <a:solidFill>
-                  <a:schemeClr val="tx1"/>
-                </a:solidFill>
-              </a:rPr>
-              <a:t>☐  Read every approval before clicking</a:t>
+              <a:buNone/>
+            </a:pPr>
+            <a:r>
+              <a:rPr lang="en-US" sz="1200" dirty="0">
+                <a:solidFill>
+                  <a:schemeClr val="tx2"/>
+                </a:solidFill>
+              </a:rPr>
+              <a:t>The cost view. Filter by source: All LLMs, group by source: daily LLM cost by Gemini model. Narrow it to your project or usage account.</a:t>
             </a:r>
             <a:endParaRPr lang="en-US" sz="1500" dirty="0"/>
           </a:p>
-          <a:p>
-            <a:pPr indent="0" marL="0">
-              <a:spcAft>
-                <a:spcPts val="1400"/>
-              </a:spcAft>
-              <a:buNone/>
-            </a:pPr>
-            <a:r>
-              <a:rPr lang="en-US" sz="1500" dirty="0">
-                <a:solidFill>
-                  <a:schemeClr val="tx1"/>
-                </a:solidFill>
-              </a:rPr>
-              <a:t>☐  Keep steps small</a:t>
-            </a:r>
-            <a:endParaRPr lang="en-US" sz="1500" dirty="0"/>
-          </a:p>
-          <a:p>
-            <a:pPr indent="0" marL="0">
-              <a:spcAft>
-                <a:spcPts val="1400"/>
-              </a:spcAft>
-              <a:buNone/>
-            </a:pPr>
-            <a:r>
-              <a:rPr lang="en-US" sz="1500" dirty="0">
-                <a:solidFill>
-                  <a:schemeClr val="tx1"/>
-                </a:solidFill>
-              </a:rPr>
-              <a:t>☐  Watch token counts; compact</a:t>
-            </a:r>
-            <a:endParaRPr lang="en-US" sz="1500" dirty="0"/>
-          </a:p>
-          <a:p>
-            <a:pPr indent="0" marL="0">
-              <a:spcAft>
-                <a:spcPts val="1400"/>
-              </a:spcAft>
-              <a:buNone/>
-            </a:pPr>
-            <a:r>
-              <a:rPr lang="en-US" sz="1500" dirty="0">
-                <a:solidFill>
-                  <a:schemeClr val="tx1"/>
-                </a:solidFill>
-              </a:rPr>
-              <a:t>☐  Stop it if it goes in circles</a:t>
-            </a:r>
-            <a:endParaRPr lang="en-US" sz="1500" dirty="0"/>
-          </a:p>
-        </p:txBody>
-      </p:sp>
-      <p:sp>
-        <p:nvSpPr>
-          <p:cNvPr id="12" name="ck-2"/>
-          <p:cNvSpPr/>
-          <p:nvPr/>
-        </p:nvSpPr>
-        <p:spPr>
-          <a:xfrm>
-            <a:off x="8127797" y="1417320"/>
-            <a:ext cx="3515258" cy="4937760"/>
+        </p:txBody>
+      </p:sp>
+      <p:sp>
+        <p:nvSpPr>
+          <p:cNvPr id="13" name="rm-2"/>
+          <p:cNvSpPr/>
+          <p:nvPr/>
+        </p:nvSpPr>
+        <p:spPr>
+          <a:xfrm>
+            <a:off x="548640" y="4059936"/>
+            <a:ext cx="6675120" cy="1097280"/>
           </a:xfrm>
           <a:prstGeom prst="roundRect">
             <a:avLst>
-              <a:gd name="adj" fmla="val 3121"/>
+              <a:gd name="adj" fmla="val 10000"/>
             </a:avLst>
           </a:prstGeom>
           <a:solidFill>
@@ -3431,16 +3447,16 @@
       </p:sp>
       <p:sp>
         <p:nvSpPr>
-          <p:cNvPr id="13" name="ck-2-bar"/>
-          <p:cNvSpPr/>
-          <p:nvPr/>
-        </p:nvSpPr>
-        <p:spPr>
-          <a:xfrm>
-            <a:off x="8127797" y="1417320"/>
-            <a:ext cx="3515258" cy="109728"/>
-          </a:xfrm>
-          <a:prstGeom prst="rect">
+          <p:cNvPr id="14" name="rm-2-n"/>
+          <p:cNvSpPr/>
+          <p:nvPr/>
+        </p:nvSpPr>
+        <p:spPr>
+          <a:xfrm>
+            <a:off x="777240" y="4352544"/>
+            <a:ext cx="512064" cy="512064"/>
+          </a:xfrm>
+          <a:prstGeom prst="ellipse">
             <a:avLst/>
           </a:prstGeom>
           <a:solidFill>
@@ -3451,14 +3467,169 @@
       </p:sp>
       <p:sp>
         <p:nvSpPr>
-          <p:cNvPr id="14" name="ck-2-h"/>
+          <p:cNvPr id="15" name="rm-2-nt"/>
           <p:cNvSpPr txBox="1"/>
           <p:nvPr/>
         </p:nvSpPr>
         <p:spPr>
           <a:xfrm>
-            <a:off x="8402117" y="1691640"/>
-            <a:ext cx="2966618" cy="365760"/>
+            <a:off x="777240" y="4352544"/>
+            <a:ext cx="512064" cy="512064"/>
+          </a:xfrm>
+          <a:prstGeom prst="rect">
+            <a:avLst/>
+          </a:prstGeom>
+          <a:noFill/>
+          <a:ln/>
+        </p:spPr>
+        <p:txBody>
+          <a:bodyPr wrap="square" lIns="0" tIns="0" rIns="0" bIns="0" rtlCol="0" anchor="ctr"/>
+          <a:lstStyle/>
+          <a:p>
+            <a:pPr algn="ctr" indent="0" marL="0">
+              <a:buNone/>
+            </a:pPr>
+            <a:r>
+              <a:rPr lang="en-US" sz="1800" b="1" dirty="0">
+                <a:solidFill>
+                  <a:schemeClr val="bg1"/>
+                </a:solidFill>
+              </a:rPr>
+              <a:t>3</a:t>
+            </a:r>
+            <a:endParaRPr lang="en-US" sz="1800" dirty="0"/>
+          </a:p>
+        </p:txBody>
+      </p:sp>
+      <p:sp>
+        <p:nvSpPr>
+          <p:cNvPr id="16" name="rm-2-t"/>
+          <p:cNvSpPr txBox="1"/>
+          <p:nvPr/>
+        </p:nvSpPr>
+        <p:spPr>
+          <a:xfrm>
+            <a:off x="1508760" y="4059936"/>
+            <a:ext cx="5486400" cy="1097280"/>
+          </a:xfrm>
+          <a:prstGeom prst="rect">
+            <a:avLst/>
+          </a:prstGeom>
+          <a:noFill/>
+          <a:ln/>
+        </p:spPr>
+        <p:txBody>
+          <a:bodyPr wrap="square" lIns="0" tIns="0" rIns="0" bIns="0" rtlCol="0" anchor="ctr"/>
+          <a:lstStyle/>
+          <a:p>
+            <a:pPr indent="0" marL="0">
+              <a:buNone/>
+            </a:pPr>
+            <a:r>
+              <a:rPr lang="en-US" sz="1500" b="1" dirty="0">
+                <a:solidFill>
+                  <a:schemeClr val="tx1"/>
+                </a:solidFill>
+              </a:rPr>
+              <a:t>Budgets</a:t>
+            </a:r>
+            <a:endParaRPr lang="en-US" sz="1500" dirty="0"/>
+          </a:p>
+          <a:p>
+            <a:pPr indent="0" marL="0">
+              <a:buNone/>
+            </a:pPr>
+            <a:r>
+              <a:rPr lang="en-US" sz="1200" dirty="0">
+                <a:solidFill>
+                  <a:schemeClr val="tx2"/>
+                </a:solidFill>
+              </a:rPr>
+              <a:t>Set by the platform admins: a monthly budget on our usage account, with notification thresholds and the people to notify.</a:t>
+            </a:r>
+            <a:endParaRPr lang="en-US" sz="1500" dirty="0"/>
+          </a:p>
+        </p:txBody>
+      </p:sp>
+      <p:sp>
+        <p:nvSpPr>
+          <p:cNvPr id="17" name="rm-habit"/>
+          <p:cNvSpPr txBox="1"/>
+          <p:nvPr/>
+        </p:nvSpPr>
+        <p:spPr>
+          <a:xfrm>
+            <a:off x="548640" y="5349240"/>
+            <a:ext cx="6675120" cy="822960"/>
+          </a:xfrm>
+          <a:prstGeom prst="rect">
+            <a:avLst/>
+          </a:prstGeom>
+          <a:noFill/>
+          <a:ln/>
+        </p:spPr>
+        <p:txBody>
+          <a:bodyPr wrap="square" lIns="0" tIns="0" rIns="0" bIns="0" rtlCol="0" anchor="ctr"/>
+          <a:lstStyle/>
+          <a:p>
+            <a:pPr indent="0" marL="0">
+              <a:buNone/>
+            </a:pPr>
+            <a:r>
+              <a:rPr lang="en-US" sz="1300" b="1" dirty="0">
+                <a:solidFill>
+                  <a:schemeClr val="accent3"/>
+                </a:solidFill>
+              </a:rPr>
+              <a:t>Habit  </a:t>
+            </a:r>
+            <a:pPr indent="0" marL="0">
+              <a:buNone/>
+            </a:pPr>
+            <a:r>
+              <a:rPr lang="en-US" sz="1300" dirty="0">
+                <a:solidFill>
+                  <a:schemeClr val="tx1"/>
+                </a:solidFill>
+              </a:rPr>
+              <a:t>Check your project's LLM cost once a week. A spike? Find the session in the chat outline's token counts and fix the habit.</a:t>
+            </a:r>
+            <a:endParaRPr lang="en-US" sz="1300" dirty="0"/>
+          </a:p>
+        </p:txBody>
+      </p:sp>
+      <p:sp>
+        <p:nvSpPr>
+          <p:cNvPr id="18" name="rm-esc"/>
+          <p:cNvSpPr/>
+          <p:nvPr/>
+        </p:nvSpPr>
+        <p:spPr>
+          <a:xfrm>
+            <a:off x="7498080" y="1645920"/>
+            <a:ext cx="4144975" cy="4709160"/>
+          </a:xfrm>
+          <a:prstGeom prst="roundRect">
+            <a:avLst>
+              <a:gd name="adj" fmla="val 2647"/>
+            </a:avLst>
+          </a:prstGeom>
+          <a:solidFill>
+            <a:schemeClr val="tx1"/>
+          </a:solidFill>
+          <a:ln/>
+        </p:spPr>
+      </p:sp>
+      <p:sp>
+        <p:nvSpPr>
+          <p:cNvPr id="19" name="h-OVER THE THR"/>
+          <p:cNvSpPr txBox="1"/>
+          <p:nvPr/>
+        </p:nvSpPr>
+        <p:spPr>
+          <a:xfrm>
+            <a:off x="7818120" y="1828800"/>
+            <a:ext cx="3504895" cy="274320"/>
           </a:xfrm>
           <a:prstGeom prst="rect">
             <a:avLst/>
@@ -3474,119 +3645,276 @@
               <a:buNone/>
             </a:pPr>
             <a:r>
-              <a:rPr lang="en-US" sz="1800" b="1" spc="200" kern="0" dirty="0">
-                <a:solidFill>
-                  <a:schemeClr val="accent4"/>
-                </a:solidFill>
-              </a:rPr>
-              <a:t>AFTER</a:t>
-            </a:r>
-            <a:endParaRPr lang="en-US" sz="1800" dirty="0"/>
-          </a:p>
-        </p:txBody>
-      </p:sp>
-      <p:sp>
-        <p:nvSpPr>
-          <p:cNvPr id="15" name="ck-2-l"/>
+              <a:rPr lang="en-US" sz="1100" b="1" spc="100" kern="0" dirty="0">
+                <a:solidFill>
+                  <a:schemeClr val="accent5"/>
+                </a:solidFill>
+              </a:rPr>
+              <a:t>OVER THE THRESHOLD</a:t>
+            </a:r>
+            <a:endParaRPr lang="en-US" sz="1100" dirty="0"/>
+          </a:p>
+        </p:txBody>
+      </p:sp>
+      <p:sp>
+        <p:nvSpPr>
+          <p:cNvPr id="20" name="rm-f-0"/>
+          <p:cNvSpPr/>
+          <p:nvPr/>
+        </p:nvSpPr>
+        <p:spPr>
+          <a:xfrm>
+            <a:off x="7818120" y="2286000"/>
+            <a:ext cx="3504895" cy="914400"/>
+          </a:xfrm>
+          <a:prstGeom prst="roundRect">
+            <a:avLst>
+              <a:gd name="adj" fmla="val 12000"/>
+            </a:avLst>
+          </a:prstGeom>
+          <a:solidFill>
+            <a:srgbClr val="1A3A7A"/>
+          </a:solidFill>
+          <a:ln/>
+        </p:spPr>
+      </p:sp>
+      <p:sp>
+        <p:nvSpPr>
+          <p:cNvPr id="21" name="rm-f-0-t"/>
           <p:cNvSpPr txBox="1"/>
           <p:nvPr/>
         </p:nvSpPr>
         <p:spPr>
           <a:xfrm>
-            <a:off x="8402117" y="2194560"/>
-            <a:ext cx="2966618" cy="4023360"/>
-          </a:xfrm>
-          <a:prstGeom prst="rect">
-            <a:avLst/>
-          </a:prstGeom>
-          <a:noFill/>
-          <a:ln/>
-        </p:spPr>
-        <p:txBody>
-          <a:bodyPr wrap="square" lIns="0" tIns="0" rIns="0" bIns="0" rtlCol="0" anchor="t"/>
-          <a:lstStyle/>
-          <a:p>
-            <a:pPr indent="0" marL="0">
-              <a:spcAft>
-                <a:spcPts val="1400"/>
-              </a:spcAft>
-              <a:buNone/>
-            </a:pPr>
-            <a:r>
-              <a:rPr lang="en-US" sz="1500" dirty="0">
-                <a:solidFill>
-                  <a:schemeClr val="tx1"/>
-                </a:solidFill>
-              </a:rPr>
-              <a:t>☐  Review the proposal or pull request</a:t>
+            <a:off x="8046720" y="2286000"/>
+            <a:ext cx="3047695" cy="914400"/>
+          </a:xfrm>
+          <a:prstGeom prst="rect">
+            <a:avLst/>
+          </a:prstGeom>
+          <a:noFill/>
+          <a:ln/>
+        </p:spPr>
+        <p:txBody>
+          <a:bodyPr wrap="square" lIns="0" tIns="0" rIns="0" bIns="0" rtlCol="0" anchor="ctr"/>
+          <a:lstStyle/>
+          <a:p>
+            <a:pPr indent="0" marL="0">
+              <a:buNone/>
+            </a:pPr>
+            <a:r>
+              <a:rPr lang="en-US" sz="1500" b="1" dirty="0">
+                <a:solidFill>
+                  <a:schemeClr val="bg1"/>
+                </a:solidFill>
+              </a:rPr>
+              <a:t>Cost crosses the threshold</a:t>
             </a:r>
             <a:endParaRPr lang="en-US" sz="1500" dirty="0"/>
           </a:p>
           <a:p>
             <a:pPr indent="0" marL="0">
-              <a:spcAft>
-                <a:spcPts val="1400"/>
-              </a:spcAft>
-              <a:buNone/>
-            </a:pPr>
-            <a:r>
-              <a:rPr lang="en-US" sz="1500" dirty="0">
-                <a:solidFill>
-                  <a:schemeClr val="tx1"/>
-                </a:solidFill>
-              </a:rPr>
-              <a:t>☐  Test on representative sample data</a:t>
+              <a:buNone/>
+            </a:pPr>
+            <a:r>
+              <a:rPr lang="en-US" sz="1200" dirty="0">
+                <a:solidFill>
+                  <a:schemeClr val="accent5"/>
+                </a:solidFill>
+              </a:rPr>
+              <a:t>on the budget for our usage account</a:t>
             </a:r>
             <a:endParaRPr lang="en-US" sz="1500" dirty="0"/>
           </a:p>
-          <a:p>
-            <a:pPr indent="0" marL="0">
-              <a:spcAft>
-                <a:spcPts val="1400"/>
-              </a:spcAft>
-              <a:buNone/>
-            </a:pPr>
-            <a:r>
-              <a:rPr lang="en-US" sz="1500" dirty="0">
-                <a:solidFill>
-                  <a:schemeClr val="tx1"/>
-                </a:solidFill>
-              </a:rPr>
-              <a:t>☐  AIP Evals for functions</a:t>
+        </p:txBody>
+      </p:sp>
+      <p:sp>
+        <p:nvSpPr>
+          <p:cNvPr id="22" name="rm-a-0"/>
+          <p:cNvSpPr/>
+          <p:nvPr/>
+        </p:nvSpPr>
+        <p:spPr>
+          <a:xfrm>
+            <a:off x="9570568" y="3218688"/>
+            <a:ext cx="0" cy="374904"/>
+          </a:xfrm>
+          <a:prstGeom prst="line">
+            <a:avLst/>
+          </a:prstGeom>
+          <a:noFill/>
+          <a:ln w="19050">
+            <a:solidFill>
+              <a:schemeClr val="accent5"/>
+            </a:solidFill>
+            <a:prstDash val="solid"/>
+            <a:tailEnd type="triangle"/>
+          </a:ln>
+        </p:spPr>
+      </p:sp>
+      <p:sp>
+        <p:nvSpPr>
+          <p:cNvPr id="23" name="rm-f-1"/>
+          <p:cNvSpPr/>
+          <p:nvPr/>
+        </p:nvSpPr>
+        <p:spPr>
+          <a:xfrm>
+            <a:off x="7818120" y="3611880"/>
+            <a:ext cx="3504895" cy="914400"/>
+          </a:xfrm>
+          <a:prstGeom prst="roundRect">
+            <a:avLst>
+              <a:gd name="adj" fmla="val 12000"/>
+            </a:avLst>
+          </a:prstGeom>
+          <a:solidFill>
+            <a:schemeClr val="accent1"/>
+          </a:solidFill>
+          <a:ln/>
+        </p:spPr>
+      </p:sp>
+      <p:sp>
+        <p:nvSpPr>
+          <p:cNvPr id="24" name="rm-f-1-t"/>
+          <p:cNvSpPr txBox="1"/>
+          <p:nvPr/>
+        </p:nvSpPr>
+        <p:spPr>
+          <a:xfrm>
+            <a:off x="8046720" y="3611880"/>
+            <a:ext cx="3047695" cy="914400"/>
+          </a:xfrm>
+          <a:prstGeom prst="rect">
+            <a:avLst/>
+          </a:prstGeom>
+          <a:noFill/>
+          <a:ln/>
+        </p:spPr>
+        <p:txBody>
+          <a:bodyPr wrap="square" lIns="0" tIns="0" rIns="0" bIns="0" rtlCol="0" anchor="ctr"/>
+          <a:lstStyle/>
+          <a:p>
+            <a:pPr indent="0" marL="0">
+              <a:buNone/>
+            </a:pPr>
+            <a:r>
+              <a:rPr lang="en-US" sz="1500" b="1" dirty="0">
+                <a:solidFill>
+                  <a:schemeClr val="bg1"/>
+                </a:solidFill>
+              </a:rPr>
+              <a:t>Solution architect notified</a:t>
             </a:r>
             <a:endParaRPr lang="en-US" sz="1500" dirty="0"/>
           </a:p>
           <a:p>
             <a:pPr indent="0" marL="0">
-              <a:spcAft>
-                <a:spcPts val="1400"/>
-              </a:spcAft>
-              <a:buNone/>
-            </a:pPr>
-            <a:r>
-              <a:rPr lang="en-US" sz="1500" dirty="0">
-                <a:solidFill>
-                  <a:schemeClr val="tx1"/>
-                </a:solidFill>
-              </a:rPr>
-              <a:t>☐  Merge only what you understand</a:t>
+              <a:buNone/>
+            </a:pPr>
+            <a:r>
+              <a:rPr lang="en-US" sz="1200" dirty="0">
+                <a:solidFill>
+                  <a:schemeClr val="bg1"/>
+                </a:solidFill>
+              </a:rPr>
+              <a:t>with the individuals behind the usage</a:t>
             </a:r>
             <a:endParaRPr lang="en-US" sz="1500" dirty="0"/>
           </a:p>
-          <a:p>
-            <a:pPr indent="0" marL="0">
-              <a:spcAft>
-                <a:spcPts val="1400"/>
-              </a:spcAft>
-              <a:buNone/>
-            </a:pPr>
-            <a:r>
-              <a:rPr lang="en-US" sz="1500" dirty="0">
-                <a:solidFill>
-                  <a:schemeClr val="tx1"/>
-                </a:solidFill>
-              </a:rPr>
-              <a:t>☐  Save good prompts as skills</a:t>
+        </p:txBody>
+      </p:sp>
+      <p:sp>
+        <p:nvSpPr>
+          <p:cNvPr id="25" name="rm-a-1"/>
+          <p:cNvSpPr/>
+          <p:nvPr/>
+        </p:nvSpPr>
+        <p:spPr>
+          <a:xfrm>
+            <a:off x="9570568" y="4544568"/>
+            <a:ext cx="0" cy="374904"/>
+          </a:xfrm>
+          <a:prstGeom prst="line">
+            <a:avLst/>
+          </a:prstGeom>
+          <a:noFill/>
+          <a:ln w="19050">
+            <a:solidFill>
+              <a:schemeClr val="accent5"/>
+            </a:solidFill>
+            <a:prstDash val="solid"/>
+            <a:tailEnd type="triangle"/>
+          </a:ln>
+        </p:spPr>
+      </p:sp>
+      <p:sp>
+        <p:nvSpPr>
+          <p:cNvPr id="26" name="rm-f-2"/>
+          <p:cNvSpPr/>
+          <p:nvPr/>
+        </p:nvSpPr>
+        <p:spPr>
+          <a:xfrm>
+            <a:off x="7818120" y="4937760"/>
+            <a:ext cx="3504895" cy="914400"/>
+          </a:xfrm>
+          <a:prstGeom prst="roundRect">
+            <a:avLst>
+              <a:gd name="adj" fmla="val 12000"/>
+            </a:avLst>
+          </a:prstGeom>
+          <a:solidFill>
+            <a:srgbClr val="1A3A7A"/>
+          </a:solidFill>
+          <a:ln/>
+        </p:spPr>
+      </p:sp>
+      <p:sp>
+        <p:nvSpPr>
+          <p:cNvPr id="27" name="rm-f-2-t"/>
+          <p:cNvSpPr txBox="1"/>
+          <p:nvPr/>
+        </p:nvSpPr>
+        <p:spPr>
+          <a:xfrm>
+            <a:off x="8046720" y="4937760"/>
+            <a:ext cx="3047695" cy="914400"/>
+          </a:xfrm>
+          <a:prstGeom prst="rect">
+            <a:avLst/>
+          </a:prstGeom>
+          <a:noFill/>
+          <a:ln/>
+        </p:spPr>
+        <p:txBody>
+          <a:bodyPr wrap="square" lIns="0" tIns="0" rIns="0" bIns="0" rtlCol="0" anchor="ctr"/>
+          <a:lstStyle/>
+          <a:p>
+            <a:pPr indent="0" marL="0">
+              <a:buNone/>
+            </a:pPr>
+            <a:r>
+              <a:rPr lang="en-US" sz="1500" b="1" dirty="0">
+                <a:solidFill>
+                  <a:schemeClr val="bg1"/>
+                </a:solidFill>
+              </a:rPr>
+              <a:t>Review together</a:t>
+            </a:r>
+            <a:endParaRPr lang="en-US" sz="1500" dirty="0"/>
+          </a:p>
+          <a:p>
+            <a:pPr indent="0" marL="0">
+              <a:buNone/>
+            </a:pPr>
+            <a:r>
+              <a:rPr lang="en-US" sz="1200" dirty="0">
+                <a:solidFill>
+                  <a:schemeClr val="accent5"/>
+                </a:solidFill>
+              </a:rPr>
+              <a:t>what drove the cost, and the fix</a:t>
             </a:r>
             <a:endParaRPr lang="en-US" sz="1500" dirty="0"/>
           </a:p>
@@ -3644,6 +3972,677 @@
             <a:r>
               <a:rPr lang="en-US" sz="1100" b="1" spc="200" kern="0" dirty="0">
                 <a:solidFill>
+                  <a:schemeClr val="accent3"/>
+                </a:solidFill>
+              </a:rPr>
+              <a:t>CHECKLIST</a:t>
+            </a:r>
+            <a:endParaRPr lang="en-US" sz="1100" dirty="0"/>
+          </a:p>
+        </p:txBody>
+      </p:sp>
+      <p:sp>
+        <p:nvSpPr>
+          <p:cNvPr id="3" name="Text 1"/>
+          <p:cNvSpPr/>
+          <p:nvPr>
+            <p:ph idx="101" type="title" hasCustomPrompt="1"/>
+          </p:nvPr>
+        </p:nvSpPr>
+        <p:spPr>
+          <a:xfrm>
+            <a:off x="548640" y="502920"/>
+            <a:ext cx="11094415" cy="822960"/>
+          </a:xfrm>
+          <a:prstGeom prst="rect">
+            <a:avLst/>
+          </a:prstGeom>
+          <a:noFill/>
+          <a:ln/>
+        </p:spPr>
+        <p:txBody>
+          <a:bodyPr wrap="square" lIns="0" tIns="0" rIns="0" bIns="0" rtlCol="0" anchor="t"/>
+          <a:lstStyle/>
+          <a:p>
+            <a:pPr algn="l" indent="0" marL="0">
+              <a:buNone/>
+            </a:pPr>
+            <a:r>
+              <a:rPr lang="en-US" sz="3600" b="1" dirty="0">
+                <a:solidFill>
+                  <a:schemeClr val="tx1"/>
+                </a:solidFill>
+              </a:rPr>
+              <a:t>Before, during and after every session</a:t>
+            </a:r>
+            <a:endParaRPr lang="en-US" sz="3600" dirty="0"/>
+          </a:p>
+        </p:txBody>
+      </p:sp>
+      <p:sp>
+        <p:nvSpPr>
+          <p:cNvPr id="4" name="ck-0"/>
+          <p:cNvSpPr/>
+          <p:nvPr/>
+        </p:nvSpPr>
+        <p:spPr>
+          <a:xfrm>
+            <a:off x="548640" y="1417320"/>
+            <a:ext cx="3515258" cy="4937760"/>
+          </a:xfrm>
+          <a:prstGeom prst="roundRect">
+            <a:avLst>
+              <a:gd name="adj" fmla="val 3121"/>
+            </a:avLst>
+          </a:prstGeom>
+          <a:solidFill>
+            <a:schemeClr val="bg2"/>
+          </a:solidFill>
+          <a:ln/>
+        </p:spPr>
+      </p:sp>
+      <p:sp>
+        <p:nvSpPr>
+          <p:cNvPr id="5" name="ck-0-bar"/>
+          <p:cNvSpPr/>
+          <p:nvPr/>
+        </p:nvSpPr>
+        <p:spPr>
+          <a:xfrm>
+            <a:off x="548640" y="1417320"/>
+            <a:ext cx="3515258" cy="109728"/>
+          </a:xfrm>
+          <a:prstGeom prst="rect">
+            <a:avLst/>
+          </a:prstGeom>
+          <a:solidFill>
+            <a:schemeClr val="accent1"/>
+          </a:solidFill>
+          <a:ln/>
+        </p:spPr>
+      </p:sp>
+      <p:sp>
+        <p:nvSpPr>
+          <p:cNvPr id="6" name="ck-0-h"/>
+          <p:cNvSpPr txBox="1"/>
+          <p:nvPr/>
+        </p:nvSpPr>
+        <p:spPr>
+          <a:xfrm>
+            <a:off x="822960" y="1691640"/>
+            <a:ext cx="2966618" cy="365760"/>
+          </a:xfrm>
+          <a:prstGeom prst="rect">
+            <a:avLst/>
+          </a:prstGeom>
+          <a:noFill/>
+          <a:ln/>
+        </p:spPr>
+        <p:txBody>
+          <a:bodyPr wrap="square" lIns="0" tIns="0" rIns="0" bIns="0" rtlCol="0" anchor="t"/>
+          <a:lstStyle/>
+          <a:p>
+            <a:pPr indent="0" marL="0">
+              <a:buNone/>
+            </a:pPr>
+            <a:r>
+              <a:rPr lang="en-US" sz="1800" b="1" spc="200" kern="0" dirty="0">
+                <a:solidFill>
+                  <a:schemeClr val="accent1"/>
+                </a:solidFill>
+              </a:rPr>
+              <a:t>BEFORE</a:t>
+            </a:r>
+            <a:endParaRPr lang="en-US" sz="1800" dirty="0"/>
+          </a:p>
+        </p:txBody>
+      </p:sp>
+      <p:sp>
+        <p:nvSpPr>
+          <p:cNvPr id="7" name="ck-0-l"/>
+          <p:cNvSpPr txBox="1"/>
+          <p:nvPr/>
+        </p:nvSpPr>
+        <p:spPr>
+          <a:xfrm>
+            <a:off x="822960" y="2194560"/>
+            <a:ext cx="2966618" cy="4023360"/>
+          </a:xfrm>
+          <a:prstGeom prst="rect">
+            <a:avLst/>
+          </a:prstGeom>
+          <a:noFill/>
+          <a:ln/>
+        </p:spPr>
+        <p:txBody>
+          <a:bodyPr wrap="square" lIns="0" tIns="0" rIns="0" bIns="0" rtlCol="0" anchor="t"/>
+          <a:lstStyle/>
+          <a:p>
+            <a:pPr indent="0" marL="0">
+              <a:spcAft>
+                <a:spcPts val="1200"/>
+              </a:spcAft>
+              <a:buNone/>
+            </a:pPr>
+            <a:r>
+              <a:rPr lang="en-US" sz="1500" dirty="0">
+                <a:solidFill>
+                  <a:schemeClr val="tx1"/>
+                </a:solidFill>
+              </a:rPr>
+              <a:t>☐  New session, right mode</a:t>
+            </a:r>
+            <a:endParaRPr lang="en-US" sz="1500" dirty="0"/>
+          </a:p>
+          <a:p>
+            <a:pPr indent="0" marL="0">
+              <a:spcAft>
+                <a:spcPts val="1200"/>
+              </a:spcAft>
+              <a:buNone/>
+            </a:pPr>
+            <a:r>
+              <a:rPr lang="en-US" sz="1500" dirty="0">
+                <a:solidFill>
+                  <a:schemeClr val="tx1"/>
+                </a:solidFill>
+              </a:rPr>
+              <a:t>☐  Attach only the resources needed</a:t>
+            </a:r>
+            <a:endParaRPr lang="en-US" sz="1500" dirty="0"/>
+          </a:p>
+          <a:p>
+            <a:pPr indent="0" marL="0">
+              <a:spcAft>
+                <a:spcPts val="1200"/>
+              </a:spcAft>
+              <a:buNone/>
+            </a:pPr>
+            <a:r>
+              <a:rPr lang="en-US" sz="1500" dirty="0">
+                <a:solidFill>
+                  <a:schemeClr val="tx1"/>
+                </a:solidFill>
+              </a:rPr>
+              <a:t>☐  Switch off unused tools</a:t>
+            </a:r>
+            <a:endParaRPr lang="en-US" sz="1500" dirty="0"/>
+          </a:p>
+          <a:p>
+            <a:pPr indent="0" marL="0">
+              <a:spcAft>
+                <a:spcPts val="1200"/>
+              </a:spcAft>
+              <a:buNone/>
+            </a:pPr>
+            <a:r>
+              <a:rPr lang="en-US" sz="1500" dirty="0">
+                <a:solidFill>
+                  <a:schemeClr val="tx1"/>
+                </a:solidFill>
+              </a:rPr>
+              <a:t>☐  Gemini model to match the task</a:t>
+            </a:r>
+            <a:endParaRPr lang="en-US" sz="1500" dirty="0"/>
+          </a:p>
+          <a:p>
+            <a:pPr indent="0" marL="0">
+              <a:spcAft>
+                <a:spcPts val="1200"/>
+              </a:spcAft>
+              <a:buNone/>
+            </a:pPr>
+            <a:r>
+              <a:rPr lang="en-US" sz="1500" dirty="0">
+                <a:solidFill>
+                  <a:schemeClr val="tx1"/>
+                </a:solidFill>
+              </a:rPr>
+              <a:t>☐  Write the goal, rules and checks</a:t>
+            </a:r>
+            <a:endParaRPr lang="en-US" sz="1500" dirty="0"/>
+          </a:p>
+        </p:txBody>
+      </p:sp>
+      <p:sp>
+        <p:nvSpPr>
+          <p:cNvPr id="8" name="ck-1"/>
+          <p:cNvSpPr/>
+          <p:nvPr/>
+        </p:nvSpPr>
+        <p:spPr>
+          <a:xfrm>
+            <a:off x="4338218" y="1417320"/>
+            <a:ext cx="3515258" cy="4937760"/>
+          </a:xfrm>
+          <a:prstGeom prst="roundRect">
+            <a:avLst>
+              <a:gd name="adj" fmla="val 3121"/>
+            </a:avLst>
+          </a:prstGeom>
+          <a:solidFill>
+            <a:schemeClr val="bg2"/>
+          </a:solidFill>
+          <a:ln/>
+        </p:spPr>
+      </p:sp>
+      <p:sp>
+        <p:nvSpPr>
+          <p:cNvPr id="9" name="ck-1-bar"/>
+          <p:cNvSpPr/>
+          <p:nvPr/>
+        </p:nvSpPr>
+        <p:spPr>
+          <a:xfrm>
+            <a:off x="4338218" y="1417320"/>
+            <a:ext cx="3515258" cy="109728"/>
+          </a:xfrm>
+          <a:prstGeom prst="rect">
+            <a:avLst/>
+          </a:prstGeom>
+          <a:solidFill>
+            <a:schemeClr val="accent2"/>
+          </a:solidFill>
+          <a:ln/>
+        </p:spPr>
+      </p:sp>
+      <p:sp>
+        <p:nvSpPr>
+          <p:cNvPr id="10" name="ck-1-h"/>
+          <p:cNvSpPr txBox="1"/>
+          <p:nvPr/>
+        </p:nvSpPr>
+        <p:spPr>
+          <a:xfrm>
+            <a:off x="4612538" y="1691640"/>
+            <a:ext cx="2966618" cy="365760"/>
+          </a:xfrm>
+          <a:prstGeom prst="rect">
+            <a:avLst/>
+          </a:prstGeom>
+          <a:noFill/>
+          <a:ln/>
+        </p:spPr>
+        <p:txBody>
+          <a:bodyPr wrap="square" lIns="0" tIns="0" rIns="0" bIns="0" rtlCol="0" anchor="t"/>
+          <a:lstStyle/>
+          <a:p>
+            <a:pPr indent="0" marL="0">
+              <a:buNone/>
+            </a:pPr>
+            <a:r>
+              <a:rPr lang="en-US" sz="1800" b="1" spc="200" kern="0" dirty="0">
+                <a:solidFill>
+                  <a:schemeClr val="accent2"/>
+                </a:solidFill>
+              </a:rPr>
+              <a:t>DURING</a:t>
+            </a:r>
+            <a:endParaRPr lang="en-US" sz="1800" dirty="0"/>
+          </a:p>
+        </p:txBody>
+      </p:sp>
+      <p:sp>
+        <p:nvSpPr>
+          <p:cNvPr id="11" name="ck-1-l"/>
+          <p:cNvSpPr txBox="1"/>
+          <p:nvPr/>
+        </p:nvSpPr>
+        <p:spPr>
+          <a:xfrm>
+            <a:off x="4612538" y="2194560"/>
+            <a:ext cx="2966618" cy="4023360"/>
+          </a:xfrm>
+          <a:prstGeom prst="rect">
+            <a:avLst/>
+          </a:prstGeom>
+          <a:noFill/>
+          <a:ln/>
+        </p:spPr>
+        <p:txBody>
+          <a:bodyPr wrap="square" lIns="0" tIns="0" rIns="0" bIns="0" rtlCol="0" anchor="t"/>
+          <a:lstStyle/>
+          <a:p>
+            <a:pPr indent="0" marL="0">
+              <a:spcAft>
+                <a:spcPts val="1200"/>
+              </a:spcAft>
+              <a:buNone/>
+            </a:pPr>
+            <a:r>
+              <a:rPr lang="en-US" sz="1500" dirty="0">
+                <a:solidFill>
+                  <a:schemeClr val="tx1"/>
+                </a:solidFill>
+              </a:rPr>
+              <a:t>☐  Ask for a plan; review it</a:t>
+            </a:r>
+            <a:endParaRPr lang="en-US" sz="1500" dirty="0"/>
+          </a:p>
+          <a:p>
+            <a:pPr indent="0" marL="0">
+              <a:spcAft>
+                <a:spcPts val="1200"/>
+              </a:spcAft>
+              <a:buNone/>
+            </a:pPr>
+            <a:r>
+              <a:rPr lang="en-US" sz="1500" dirty="0">
+                <a:solidFill>
+                  <a:schemeClr val="tx1"/>
+                </a:solidFill>
+              </a:rPr>
+              <a:t>☐  Read every approval before clicking</a:t>
+            </a:r>
+            <a:endParaRPr lang="en-US" sz="1500" dirty="0"/>
+          </a:p>
+          <a:p>
+            <a:pPr indent="0" marL="0">
+              <a:spcAft>
+                <a:spcPts val="1200"/>
+              </a:spcAft>
+              <a:buNone/>
+            </a:pPr>
+            <a:r>
+              <a:rPr lang="en-US" sz="1500" dirty="0">
+                <a:solidFill>
+                  <a:schemeClr val="tx1"/>
+                </a:solidFill>
+              </a:rPr>
+              <a:t>☐  Keep steps small</a:t>
+            </a:r>
+            <a:endParaRPr lang="en-US" sz="1500" dirty="0"/>
+          </a:p>
+          <a:p>
+            <a:pPr indent="0" marL="0">
+              <a:spcAft>
+                <a:spcPts val="1200"/>
+              </a:spcAft>
+              <a:buNone/>
+            </a:pPr>
+            <a:r>
+              <a:rPr lang="en-US" sz="1500" dirty="0">
+                <a:solidFill>
+                  <a:schemeClr val="tx1"/>
+                </a:solidFill>
+              </a:rPr>
+              <a:t>☐  Watch token counts; compact</a:t>
+            </a:r>
+            <a:endParaRPr lang="en-US" sz="1500" dirty="0"/>
+          </a:p>
+          <a:p>
+            <a:pPr indent="0" marL="0">
+              <a:spcAft>
+                <a:spcPts val="1200"/>
+              </a:spcAft>
+              <a:buNone/>
+            </a:pPr>
+            <a:r>
+              <a:rPr lang="en-US" sz="1500" dirty="0">
+                <a:solidFill>
+                  <a:schemeClr val="tx1"/>
+                </a:solidFill>
+              </a:rPr>
+              <a:t>☐  Stop it if it goes in circles</a:t>
+            </a:r>
+            <a:endParaRPr lang="en-US" sz="1500" dirty="0"/>
+          </a:p>
+        </p:txBody>
+      </p:sp>
+      <p:sp>
+        <p:nvSpPr>
+          <p:cNvPr id="12" name="ck-2"/>
+          <p:cNvSpPr/>
+          <p:nvPr/>
+        </p:nvSpPr>
+        <p:spPr>
+          <a:xfrm>
+            <a:off x="8127797" y="1417320"/>
+            <a:ext cx="3515258" cy="4937760"/>
+          </a:xfrm>
+          <a:prstGeom prst="roundRect">
+            <a:avLst>
+              <a:gd name="adj" fmla="val 3121"/>
+            </a:avLst>
+          </a:prstGeom>
+          <a:solidFill>
+            <a:schemeClr val="bg2"/>
+          </a:solidFill>
+          <a:ln/>
+        </p:spPr>
+      </p:sp>
+      <p:sp>
+        <p:nvSpPr>
+          <p:cNvPr id="13" name="ck-2-bar"/>
+          <p:cNvSpPr/>
+          <p:nvPr/>
+        </p:nvSpPr>
+        <p:spPr>
+          <a:xfrm>
+            <a:off x="8127797" y="1417320"/>
+            <a:ext cx="3515258" cy="109728"/>
+          </a:xfrm>
+          <a:prstGeom prst="rect">
+            <a:avLst/>
+          </a:prstGeom>
+          <a:solidFill>
+            <a:schemeClr val="accent4"/>
+          </a:solidFill>
+          <a:ln/>
+        </p:spPr>
+      </p:sp>
+      <p:sp>
+        <p:nvSpPr>
+          <p:cNvPr id="14" name="ck-2-h"/>
+          <p:cNvSpPr txBox="1"/>
+          <p:nvPr/>
+        </p:nvSpPr>
+        <p:spPr>
+          <a:xfrm>
+            <a:off x="8402117" y="1691640"/>
+            <a:ext cx="2966618" cy="365760"/>
+          </a:xfrm>
+          <a:prstGeom prst="rect">
+            <a:avLst/>
+          </a:prstGeom>
+          <a:noFill/>
+          <a:ln/>
+        </p:spPr>
+        <p:txBody>
+          <a:bodyPr wrap="square" lIns="0" tIns="0" rIns="0" bIns="0" rtlCol="0" anchor="t"/>
+          <a:lstStyle/>
+          <a:p>
+            <a:pPr indent="0" marL="0">
+              <a:buNone/>
+            </a:pPr>
+            <a:r>
+              <a:rPr lang="en-US" sz="1800" b="1" spc="200" kern="0" dirty="0">
+                <a:solidFill>
+                  <a:schemeClr val="accent4"/>
+                </a:solidFill>
+              </a:rPr>
+              <a:t>AFTER</a:t>
+            </a:r>
+            <a:endParaRPr lang="en-US" sz="1800" dirty="0"/>
+          </a:p>
+        </p:txBody>
+      </p:sp>
+      <p:sp>
+        <p:nvSpPr>
+          <p:cNvPr id="15" name="ck-2-l"/>
+          <p:cNvSpPr txBox="1"/>
+          <p:nvPr/>
+        </p:nvSpPr>
+        <p:spPr>
+          <a:xfrm>
+            <a:off x="8402117" y="2194560"/>
+            <a:ext cx="2966618" cy="4023360"/>
+          </a:xfrm>
+          <a:prstGeom prst="rect">
+            <a:avLst/>
+          </a:prstGeom>
+          <a:noFill/>
+          <a:ln/>
+        </p:spPr>
+        <p:txBody>
+          <a:bodyPr wrap="square" lIns="0" tIns="0" rIns="0" bIns="0" rtlCol="0" anchor="t"/>
+          <a:lstStyle/>
+          <a:p>
+            <a:pPr indent="0" marL="0">
+              <a:spcAft>
+                <a:spcPts val="1200"/>
+              </a:spcAft>
+              <a:buNone/>
+            </a:pPr>
+            <a:r>
+              <a:rPr lang="en-US" sz="1500" dirty="0">
+                <a:solidFill>
+                  <a:schemeClr val="tx1"/>
+                </a:solidFill>
+              </a:rPr>
+              <a:t>☐  Review the proposal or pull request</a:t>
+            </a:r>
+            <a:endParaRPr lang="en-US" sz="1500" dirty="0"/>
+          </a:p>
+          <a:p>
+            <a:pPr indent="0" marL="0">
+              <a:spcAft>
+                <a:spcPts val="1200"/>
+              </a:spcAft>
+              <a:buNone/>
+            </a:pPr>
+            <a:r>
+              <a:rPr lang="en-US" sz="1500" dirty="0">
+                <a:solidFill>
+                  <a:schemeClr val="tx1"/>
+                </a:solidFill>
+              </a:rPr>
+              <a:t>☐  Test on representative sample data</a:t>
+            </a:r>
+            <a:endParaRPr lang="en-US" sz="1500" dirty="0"/>
+          </a:p>
+          <a:p>
+            <a:pPr indent="0" marL="0">
+              <a:spcAft>
+                <a:spcPts val="1200"/>
+              </a:spcAft>
+              <a:buNone/>
+            </a:pPr>
+            <a:r>
+              <a:rPr lang="en-US" sz="1500" dirty="0">
+                <a:solidFill>
+                  <a:schemeClr val="tx1"/>
+                </a:solidFill>
+              </a:rPr>
+              <a:t>☐  AIP Evals for functions</a:t>
+            </a:r>
+            <a:endParaRPr lang="en-US" sz="1500" dirty="0"/>
+          </a:p>
+          <a:p>
+            <a:pPr indent="0" marL="0">
+              <a:spcAft>
+                <a:spcPts val="1200"/>
+              </a:spcAft>
+              <a:buNone/>
+            </a:pPr>
+            <a:r>
+              <a:rPr lang="en-US" sz="1500" dirty="0">
+                <a:solidFill>
+                  <a:schemeClr val="tx1"/>
+                </a:solidFill>
+              </a:rPr>
+              <a:t>☐  Merge only what you understand</a:t>
+            </a:r>
+            <a:endParaRPr lang="en-US" sz="1500" dirty="0"/>
+          </a:p>
+          <a:p>
+            <a:pPr indent="0" marL="0">
+              <a:spcAft>
+                <a:spcPts val="1200"/>
+              </a:spcAft>
+              <a:buNone/>
+            </a:pPr>
+            <a:r>
+              <a:rPr lang="en-US" sz="1500" dirty="0">
+                <a:solidFill>
+                  <a:schemeClr val="tx1"/>
+                </a:solidFill>
+              </a:rPr>
+              <a:t>☐  Save good prompts as skills</a:t>
+            </a:r>
+            <a:endParaRPr lang="en-US" sz="1500" dirty="0"/>
+          </a:p>
+          <a:p>
+            <a:pPr indent="0" marL="0">
+              <a:spcAft>
+                <a:spcPts val="1200"/>
+              </a:spcAft>
+              <a:buNone/>
+            </a:pPr>
+            <a:r>
+              <a:rPr lang="en-US" sz="1500" dirty="0">
+                <a:solidFill>
+                  <a:schemeClr val="tx1"/>
+                </a:solidFill>
+              </a:rPr>
+              <a:t>☐  Check cost in Resource Management</a:t>
+            </a:r>
+            <a:endParaRPr lang="en-US" sz="1500" dirty="0"/>
+          </a:p>
+        </p:txBody>
+      </p:sp>
+    </p:spTree>
+  </p:cSld>
+  <p:clrMapOvr>
+    <a:masterClrMapping/>
+  </p:clrMapOvr>
+</p:sld>
+</file>
+
+<file path=ppt/slides/slide13.xml><?xml version="1.0" encoding="utf-8"?>
+<p:sld xmlns:a="http://schemas.openxmlformats.org/drawingml/2006/main" xmlns:r="http://schemas.openxmlformats.org/officeDocument/2006/relationships" xmlns:p="http://schemas.openxmlformats.org/presentationml/2006/main">
+  <p:cSld name="Slide 13">
+    <p:spTree>
+      <p:nvGrpSpPr>
+        <p:cNvPr id="1" name=""/>
+        <p:cNvGrpSpPr/>
+        <p:nvPr/>
+      </p:nvGrpSpPr>
+      <p:grpSpPr>
+        <a:xfrm>
+          <a:off x="0" y="0"/>
+          <a:ext cx="0" cy="0"/>
+          <a:chOff x="0" y="0"/>
+          <a:chExt cx="0" cy="0"/>
+        </a:xfrm>
+      </p:grpSpPr>
+      <p:sp>
+        <p:nvSpPr>
+          <p:cNvPr id="2" name="criterion"/>
+          <p:cNvSpPr txBox="1"/>
+          <p:nvPr/>
+        </p:nvSpPr>
+        <p:spPr>
+          <a:xfrm>
+            <a:off x="548640" y="201168"/>
+            <a:ext cx="5486400" cy="256032"/>
+          </a:xfrm>
+          <a:prstGeom prst="rect">
+            <a:avLst/>
+          </a:prstGeom>
+          <a:noFill/>
+          <a:ln/>
+        </p:spPr>
+        <p:txBody>
+          <a:bodyPr wrap="square" lIns="0" tIns="0" rIns="0" bIns="0" rtlCol="0" anchor="t"/>
+          <a:lstStyle/>
+          <a:p>
+            <a:pPr indent="0" marL="0">
+              <a:buNone/>
+            </a:pPr>
+            <a:r>
+              <a:rPr lang="en-US" sz="1100" b="1" spc="200" kern="0" dirty="0">
+                <a:solidFill>
                   <a:schemeClr val="accent5"/>
                 </a:solidFill>
               </a:rPr>
@@ -4001,7 +5000,7 @@
                   <a:schemeClr val="tx1"/>
                 </a:solidFill>
               </a:rPr>
-              <a:t>Mind the tokens</a:t>
+              <a:t>Mind the cost</a:t>
             </a:r>
             <a:endParaRPr lang="en-US" sz="1900" dirty="0"/>
           </a:p>
@@ -4029,7 +5028,7 @@
                   <a:schemeClr val="tx2"/>
                 </a:solidFill>
               </a:rPr>
-              <a:t>Short sessions, compaction, the right Gemini model</a:t>
+              <a:t>Short sessions, the right Gemini model, a weekly look in Resource Management</a:t>
             </a:r>
             <a:endParaRPr lang="en-US" sz="1900" dirty="0"/>
           </a:p>

</xml_diff>